<commit_message>
Remove iOS references from PPT slides and rebuild presentation pptx
</commit_message>
<xml_diff>
--- a/presentation.pptx
+++ b/presentation.pptx
@@ -4064,7 +4064,7 @@
             </a:r>
             <a:br/>
             <a:r>
-              <a:t>iOS 글래스모피즘 디자인 및 모바일 뷰 스위처 완벽 지원</a:t>
+              <a:t>세련된 글래스모피즘 디자인 및 모바일 뷰 스위처 완벽 지원</a:t>
             </a:r>
           </a:p>
         </p:txBody>
@@ -4922,7 +4922,7 @@
               </a:defRPr>
             </a:pPr>
             <a:r>
-              <a:t>프레임워크 종속 없는 초경량 구동, Apple iOS 스타일 글래스모피즘 및 반응형 뷰 스위처(모바일/태블릿) 탑재</a:t>
+              <a:t>프레임워크 종속 없는 초경량 구동, 모던 글래스모피즘 디자인 및 반응형 뷰 스위처(모바일/태블릿) 탑재</a:t>
             </a:r>
           </a:p>
         </p:txBody>

</xml_diff>